<commit_message>
Add the 'practically illegal' referendum slide to the emotional deck
3 national referendums in Canada since 1867, 3 in the UK's history,
zero ever in the United States (no mechanism exists). Inserted between
'the opinion of one is nothing' and the turn - it escalates the ache
from personal to structural. Deck is now 11 slides; footers renumbered.

Co-Authored-By: Claude Opus 5 <noreply@anthropic.com>
Claude-Session: https://claude.ai/code/session_01QmKUNonj5SqNy7e3K3sYT6
</commit_message>
<xml_diff>
--- a/pitch/emotional/Represent-The-Other-1460-Days.pptx
+++ b/pitch/emotional/Represent-The-Other-1460-Days.pptx
@@ -15,9 +15,10 @@
     <p:sldId id="263" r:id="rId9"/>
     <p:sldId id="264" r:id="rId10"/>
     <p:sldId id="265" r:id="rId11"/>
+    <p:sldId id="266" r:id="rId12"/>
   </p:sldIdLst>
   <p:notesMasterIdLst>
-    <p:notesMasterId r:id="rId12"/>
+    <p:notesMasterId r:id="rId13"/>
   </p:notesMasterIdLst>
   <p:sldSz cx="12192000" cy="6858000"/>
   <p:notesSz cx="6858000" cy="12192000"/>
@@ -599,7 +600,7 @@
           <a:p>
             <a:r>
               <a:rPr lang="en-US" dirty="0"/>
-              <a:t>We are not asking anyone to fund an app. We are asking them to help prove that the majority chooses good — because if that is true, everything about how we govern ourselves changes. Every generation before us wanted this. We are the first one that can actually build it. It exists. It is live. It is small. Help us make it inevitable.</a:t>
+              <a:t>So why am I doing this? Because I believe something our entire system quietly does not: when people get the chance to decide for themselves, they choose good. Not every person, not every time. But the majority, over time, chooses good. Every civilization that collapsed, collapsed on decisions ordinary people would never have made — and in every one of them, the good people were the majority. They just never had an instrument. Everything about how we are governed assumes people cannot be trusted with decisions. Represent is the opposite bet.</a:t>
             </a:r>
             <a:endParaRPr lang="en-US" dirty="0"/>
           </a:p>
@@ -623,6 +624,94 @@
             <a:fld id="{F7021451-1387-4CA6-816F-3879F97B5CBC}" type="slidenum">
               <a:rPr lang="en-US"/>
               <a:t>10</a:t>
+            </a:fld>
+            <a:endParaRPr lang="en-US"/>
+          </a:p>
+        </p:txBody>
+      </p:sp>
+    </p:spTree>
+    <p:extLst>
+      <p:ext uri="{BB962C8B-B14F-4D97-AF65-F5344CB8AC3E}">
+        <p14:creationId xmlns:p14="http://schemas.microsoft.com/office/powerpoint/2010/main" val="1024086991"/>
+      </p:ext>
+    </p:extLst>
+  </p:cSld>
+  <p:clrMapOvr>
+    <a:masterClrMapping/>
+  </p:clrMapOvr>
+</p:notes>
+</file>
+
+<file path=ppt/notesSlides/notesSlide11.xml><?xml version="1.0" encoding="utf-8"?>
+<p:notes xmlns:a="http://schemas.openxmlformats.org/drawingml/2006/main" xmlns:r="http://schemas.openxmlformats.org/officeDocument/2006/relationships" xmlns:p="http://schemas.openxmlformats.org/presentationml/2006/main">
+  <p:cSld>
+    <p:spTree>
+      <p:nvGrpSpPr>
+        <p:cNvPr id="1" name=""/>
+        <p:cNvGrpSpPr/>
+        <p:nvPr/>
+      </p:nvGrpSpPr>
+      <p:grpSpPr>
+        <a:xfrm>
+          <a:off x="0" y="0"/>
+          <a:ext cx="0" cy="0"/>
+          <a:chOff x="0" y="0"/>
+          <a:chExt cx="0" cy="0"/>
+        </a:xfrm>
+      </p:grpSpPr>
+      <p:sp>
+        <p:nvSpPr>
+          <p:cNvPr id="2" name="Slide Image Placeholder 1"/>
+          <p:cNvSpPr>
+            <a:spLocks noGrp="1" noRot="1" noChangeAspect="1"/>
+          </p:cNvSpPr>
+          <p:nvPr>
+            <p:ph type="sldImg"/>
+          </p:nvPr>
+        </p:nvSpPr>
+        <p:spPr/>
+      </p:sp>
+      <p:sp>
+        <p:nvSpPr>
+          <p:cNvPr id="3" name="Notes Placeholder 2"/>
+          <p:cNvSpPr>
+            <a:spLocks noGrp="1"/>
+          </p:cNvSpPr>
+          <p:nvPr>
+            <p:ph type="body" idx="1"/>
+          </p:nvPr>
+        </p:nvSpPr>
+        <p:spPr/>
+        <p:txBody>
+          <a:bodyPr/>
+          <a:lstStyle/>
+          <a:p>
+            <a:r>
+              <a:rPr lang="en-US" dirty="0"/>
+              <a:t>We are not asking anyone to fund an app. We are asking them to help prove that the majority chooses good — because if that is true, everything about how we govern ourselves changes. Every generation before us wanted this. We are the first one that can actually build it. It exists. It is live. It is small. Help us make it inevitable.</a:t>
+            </a:r>
+            <a:endParaRPr lang="en-US" dirty="0"/>
+          </a:p>
+        </p:txBody>
+      </p:sp>
+      <p:sp>
+        <p:nvSpPr>
+          <p:cNvPr id="4" name="Slide Number Placeholder 3"/>
+          <p:cNvSpPr>
+            <a:spLocks noGrp="1"/>
+          </p:cNvSpPr>
+          <p:nvPr>
+            <p:ph type="sldNum" sz="quarter" idx="10"/>
+          </p:nvPr>
+        </p:nvSpPr>
+        <p:spPr/>
+        <p:txBody>
+          <a:bodyPr/>
+          <a:lstStyle/>
+          <a:p>
+            <a:fld id="{F7021451-1387-4CA6-816F-3879F97B5CBC}" type="slidenum">
+              <a:rPr lang="en-US"/>
+              <a:t>11</a:t>
             </a:fld>
             <a:endParaRPr lang="en-US"/>
           </a:p>
@@ -1039,7 +1128,7 @@
           <a:p>
             <a:r>
               <a:rPr lang="en-US" dirty="0"/>
-              <a:t>Pause before this slide. Then: You get one day every four years. We built the other one thousand, four hundred and sixty.</a:t>
+              <a:t>And it is not just you. Ask how often the country itself asks its people a question. Canada: three national referendums since 1867 - the last one in 1992. Britain: three in its entire history. The United States: zero. Not once in 250 years - there is no legal mechanism to even hold one. Asking the people is practically illegal. If you are under fifty-two, Canada has never asked you a single question in your life.</a:t>
             </a:r>
             <a:endParaRPr lang="en-US" dirty="0"/>
           </a:p>
@@ -1127,7 +1216,7 @@
           <a:p>
             <a:r>
               <a:rPr lang="en-US" dirty="0"/>
-              <a:t>Represent is live on the App Store right now. But forget the technology — we have had this technology for twenty-five years. Here is what it actually is: a mom in Calgary deciding whether her kid’s school gets built, from her kitchen table, on a Tuesday night. Verified as one real person, counted once, on a public record. And a feeling most people have never had: being asked. Being asked feels like being respected.</a:t>
+              <a:t>Pause before this slide. Then: You get one day every four years. We built the other one thousand, four hundred and sixty.</a:t>
             </a:r>
             <a:endParaRPr lang="en-US" dirty="0"/>
           </a:p>
@@ -1215,7 +1304,7 @@
           <a:p>
             <a:r>
               <a:rPr lang="en-US" dirty="0"/>
-              <a:t>The last time this city dared to ask its people one question — the 2018 Olympic plebiscite — the vote cost 2.2 million dollars, the process took the better part of three years, and the infrastructure was dismantled the next day. On Represent, that question is free, and it closes by Friday.</a:t>
+              <a:t>Represent is live on the App Store right now. But forget the technology — we have had this technology for twenty-five years. Here is what it actually is: a mom in Calgary deciding whether her kid’s school gets built, from her kitchen table, on a Tuesday night. Verified as one real person, counted once, on a public record. And a feeling most people have never had: being asked. Being asked feels like being respected.</a:t>
             </a:r>
             <a:endParaRPr lang="en-US" dirty="0"/>
           </a:p>
@@ -1303,7 +1392,7 @@
           <a:p>
             <a:r>
               <a:rPr lang="en-US" dirty="0"/>
-              <a:t>So why am I doing this? Because I believe something our entire system quietly does not: when people get the chance to decide for themselves, they choose good. Not every person, not every time. But the majority, over time, chooses good. Every civilization that collapsed, collapsed on decisions ordinary people would never have made — and in every one of them, the good people were the majority. They just never had an instrument. Everything about how we are governed assumes people cannot be trusted with decisions. Represent is the opposite bet.</a:t>
+              <a:t>The last time this city dared to ask its people one question — the 2018 Olympic plebiscite — the vote cost 2.2 million dollars, the process took the better part of three years, and the infrastructure was dismantled the next day. On Represent, that question is free, and it closes by Friday.</a:t>
             </a:r>
             <a:endParaRPr lang="en-US" dirty="0"/>
           </a:p>
@@ -1748,7 +1837,7 @@
                 <a:ea typeface="Courier New" pitchFamily="34" charset="-122"/>
                 <a:cs typeface="Courier New" pitchFamily="34" charset="-120"/>
               </a:rPr>
-              <a:t>01 / 10</a:t>
+              <a:t>01 / 11</a:t>
             </a:r>
             <a:endParaRPr lang="en-US" sz="1000" dirty="0"/>
           </a:p>
@@ -2183,7 +2272,179 @@
                 <a:ea typeface="Courier New" pitchFamily="34" charset="-122"/>
                 <a:cs typeface="Courier New" pitchFamily="34" charset="-120"/>
               </a:rPr>
-              <a:t>10 / 10</a:t>
+              <a:t>10 / 11</a:t>
+            </a:r>
+            <a:endParaRPr lang="en-US" sz="1000" dirty="0"/>
+          </a:p>
+        </p:txBody>
+      </p:sp>
+      <p:sp>
+        <p:nvSpPr>
+          <p:cNvPr id="5" name="Text 2"/>
+          <p:cNvSpPr txBox="1"/>
+          <p:nvPr/>
+        </p:nvSpPr>
+        <p:spPr>
+          <a:xfrm>
+            <a:off x="822960" y="2103120"/>
+            <a:ext cx="10545775" cy="2926080"/>
+          </a:xfrm>
+          <a:prstGeom prst="rect">
+            <a:avLst/>
+          </a:prstGeom>
+          <a:noFill/>
+          <a:ln/>
+        </p:spPr>
+        <p:txBody>
+          <a:bodyPr wrap="square" lIns="0" tIns="0" rIns="0" bIns="0" rtlCol="0" anchor="t"/>
+          <a:lstStyle/>
+          <a:p>
+            <a:pPr algn="ctr" indent="0" marL="0">
+              <a:lnSpc>
+                <a:spcPct val="118000"/>
+              </a:lnSpc>
+              <a:buNone/>
+            </a:pPr>
+            <a:r>
+              <a:rPr lang="en-US" sz="8000" dirty="0">
+                <a:solidFill>
+                  <a:srgbClr val="EABA58"/>
+                </a:solidFill>
+                <a:latin typeface="Cambria" pitchFamily="34" charset="0"/>
+                <a:ea typeface="Cambria" pitchFamily="34" charset="-122"/>
+                <a:cs typeface="Cambria" pitchFamily="34" charset="-120"/>
+              </a:rPr>
+              <a:t>The majority</a:t>
+            </a:r>
+            <a:endParaRPr lang="en-US" sz="8000" dirty="0"/>
+          </a:p>
+          <a:p>
+            <a:pPr algn="ctr" indent="0" marL="0">
+              <a:lnSpc>
+                <a:spcPct val="118000"/>
+              </a:lnSpc>
+              <a:buNone/>
+            </a:pPr>
+            <a:r>
+              <a:rPr lang="en-US" sz="8000" dirty="0">
+                <a:solidFill>
+                  <a:srgbClr val="EABA58"/>
+                </a:solidFill>
+                <a:latin typeface="Cambria" pitchFamily="34" charset="0"/>
+                <a:ea typeface="Cambria" pitchFamily="34" charset="-122"/>
+                <a:cs typeface="Cambria" pitchFamily="34" charset="-120"/>
+              </a:rPr>
+              <a:t>chooses good.</a:t>
+            </a:r>
+            <a:endParaRPr lang="en-US" sz="8000" dirty="0"/>
+          </a:p>
+        </p:txBody>
+      </p:sp>
+    </p:spTree>
+  </p:cSld>
+  <p:clrMapOvr>
+    <a:masterClrMapping/>
+  </p:clrMapOvr>
+</p:sld>
+</file>
+
+<file path=ppt/slides/slide11.xml><?xml version="1.0" encoding="utf-8"?>
+<p:sld xmlns:a="http://schemas.openxmlformats.org/drawingml/2006/main" xmlns:r="http://schemas.openxmlformats.org/officeDocument/2006/relationships" xmlns:p="http://schemas.openxmlformats.org/presentationml/2006/main">
+  <p:cSld name="Slide 11">
+    <p:bg>
+      <p:bgPr>
+        <a:solidFill>
+          <a:srgbClr val="040707"/>
+        </a:solidFill>
+      </p:bgPr>
+    </p:bg>
+    <p:spTree>
+      <p:nvGrpSpPr>
+        <p:cNvPr id="1" name=""/>
+        <p:cNvGrpSpPr/>
+        <p:nvPr/>
+      </p:nvGrpSpPr>
+      <p:grpSpPr>
+        <a:xfrm>
+          <a:off x="0" y="0"/>
+          <a:ext cx="0" cy="0"/>
+          <a:chOff x="0" y="0"/>
+          <a:chExt cx="0" cy="0"/>
+        </a:xfrm>
+      </p:grpSpPr>
+      <p:sp>
+        <p:nvSpPr>
+          <p:cNvPr id="2" name="Text 0"/>
+          <p:cNvSpPr txBox="1"/>
+          <p:nvPr/>
+        </p:nvSpPr>
+        <p:spPr>
+          <a:xfrm>
+            <a:off x="822960" y="6291072"/>
+            <a:ext cx="2743200" cy="274320"/>
+          </a:xfrm>
+          <a:prstGeom prst="rect">
+            <a:avLst/>
+          </a:prstGeom>
+          <a:noFill/>
+          <a:ln/>
+        </p:spPr>
+        <p:txBody>
+          <a:bodyPr wrap="square" lIns="0" tIns="0" rIns="0" bIns="0" rtlCol="0" anchor="ctr"/>
+          <a:lstStyle/>
+          <a:p>
+            <a:pPr indent="0" marL="0">
+              <a:buNone/>
+            </a:pPr>
+            <a:r>
+              <a:rPr lang="en-US" sz="1000" spc="400" kern="0" dirty="0">
+                <a:solidFill>
+                  <a:srgbClr val="7A7D7E"/>
+                </a:solidFill>
+                <a:latin typeface="Courier New" pitchFamily="34" charset="0"/>
+                <a:ea typeface="Courier New" pitchFamily="34" charset="-122"/>
+                <a:cs typeface="Courier New" pitchFamily="34" charset="-120"/>
+              </a:rPr>
+              <a:t>REPRESENT</a:t>
+            </a:r>
+            <a:endParaRPr lang="en-US" sz="1000" dirty="0"/>
+          </a:p>
+        </p:txBody>
+      </p:sp>
+      <p:sp>
+        <p:nvSpPr>
+          <p:cNvPr id="3" name="Text 1"/>
+          <p:cNvSpPr txBox="1"/>
+          <p:nvPr/>
+        </p:nvSpPr>
+        <p:spPr>
+          <a:xfrm>
+            <a:off x="9539935" y="6291072"/>
+            <a:ext cx="1828800" cy="274320"/>
+          </a:xfrm>
+          <a:prstGeom prst="rect">
+            <a:avLst/>
+          </a:prstGeom>
+          <a:noFill/>
+          <a:ln/>
+        </p:spPr>
+        <p:txBody>
+          <a:bodyPr wrap="square" lIns="0" tIns="0" rIns="0" bIns="0" rtlCol="0" anchor="ctr"/>
+          <a:lstStyle/>
+          <a:p>
+            <a:pPr algn="r" indent="0" marL="0">
+              <a:buNone/>
+            </a:pPr>
+            <a:r>
+              <a:rPr lang="en-US" sz="1000" spc="200" kern="0" dirty="0">
+                <a:solidFill>
+                  <a:srgbClr val="7A7D7E"/>
+                </a:solidFill>
+                <a:latin typeface="Courier New" pitchFamily="34" charset="0"/>
+                <a:ea typeface="Courier New" pitchFamily="34" charset="-122"/>
+                <a:cs typeface="Courier New" pitchFamily="34" charset="-120"/>
+              </a:rPr>
+              <a:t>11 / 11</a:t>
             </a:r>
             <a:endParaRPr lang="en-US" sz="1000" dirty="0"/>
           </a:p>
@@ -2418,7 +2679,7 @@
                 <a:ea typeface="Courier New" pitchFamily="34" charset="-122"/>
                 <a:cs typeface="Courier New" pitchFamily="34" charset="-120"/>
               </a:rPr>
-              <a:t>02 / 10</a:t>
+              <a:t>02 / 11</a:t>
             </a:r>
             <a:endParaRPr lang="en-US" sz="1000" dirty="0"/>
           </a:p>
@@ -2829,7 +3090,7 @@
                 <a:ea typeface="Courier New" pitchFamily="34" charset="-122"/>
                 <a:cs typeface="Courier New" pitchFamily="34" charset="-120"/>
               </a:rPr>
-              <a:t>03 / 10</a:t>
+              <a:t>03 / 11</a:t>
             </a:r>
             <a:endParaRPr lang="en-US" sz="1000" dirty="0"/>
           </a:p>
@@ -3095,7 +3356,7 @@
                 <a:ea typeface="Courier New" pitchFamily="34" charset="-122"/>
                 <a:cs typeface="Courier New" pitchFamily="34" charset="-120"/>
               </a:rPr>
-              <a:t>04 / 10</a:t>
+              <a:t>04 / 11</a:t>
             </a:r>
             <a:endParaRPr lang="en-US" sz="1000" dirty="0"/>
           </a:p>
@@ -3526,7 +3787,7 @@
                 <a:ea typeface="Courier New" pitchFamily="34" charset="-122"/>
                 <a:cs typeface="Courier New" pitchFamily="34" charset="-120"/>
               </a:rPr>
-              <a:t>05 / 10</a:t>
+              <a:t>05 / 11</a:t>
             </a:r>
             <a:endParaRPr lang="en-US" sz="1000" dirty="0"/>
           </a:p>
@@ -3932,7 +4193,7 @@
                 <a:ea typeface="Courier New" pitchFamily="34" charset="-122"/>
                 <a:cs typeface="Courier New" pitchFamily="34" charset="-120"/>
               </a:rPr>
-              <a:t>06 / 10</a:t>
+              <a:t>06 / 11</a:t>
             </a:r>
             <a:endParaRPr lang="en-US" sz="1000" dirty="0"/>
           </a:p>
@@ -3946,27 +4207,102 @@
         </p:nvSpPr>
         <p:spPr>
           <a:xfrm>
+            <a:off x="822960" y="1234440"/>
+            <a:ext cx="10545775" cy="310896"/>
+          </a:xfrm>
+          <a:prstGeom prst="rect">
+            <a:avLst/>
+          </a:prstGeom>
+          <a:noFill/>
+          <a:ln/>
+        </p:spPr>
+        <p:txBody>
+          <a:bodyPr wrap="square" lIns="0" tIns="0" rIns="0" bIns="0" rtlCol="0" anchor="ctr"/>
+          <a:lstStyle/>
+          <a:p>
+            <a:pPr algn="l" indent="0" marL="0">
+              <a:buNone/>
+            </a:pPr>
+            <a:r>
+              <a:rPr lang="en-US" sz="1300" spc="500" kern="0" dirty="0">
+                <a:solidFill>
+                  <a:srgbClr val="EABA58"/>
+                </a:solidFill>
+                <a:latin typeface="Courier New" pitchFamily="34" charset="0"/>
+                <a:ea typeface="Courier New" pitchFamily="34" charset="-122"/>
+                <a:cs typeface="Courier New" pitchFamily="34" charset="-120"/>
+              </a:rPr>
+              <a:t>HOW OFTEN DOES YOUR COUNTRY ASK YOU A QUESTION?</a:t>
+            </a:r>
+            <a:endParaRPr lang="en-US" sz="1300" dirty="0"/>
+          </a:p>
+        </p:txBody>
+      </p:sp>
+      <p:sp>
+        <p:nvSpPr>
+          <p:cNvPr id="6" name="Text 3"/>
+          <p:cNvSpPr txBox="1"/>
+          <p:nvPr/>
+        </p:nvSpPr>
+        <p:spPr>
+          <a:xfrm>
+            <a:off x="822960" y="1828800"/>
+            <a:ext cx="3291840" cy="329184"/>
+          </a:xfrm>
+          <a:prstGeom prst="rect">
+            <a:avLst/>
+          </a:prstGeom>
+          <a:noFill/>
+          <a:ln/>
+        </p:spPr>
+        <p:txBody>
+          <a:bodyPr wrap="square" lIns="0" tIns="0" rIns="0" bIns="0" rtlCol="0" anchor="ctr"/>
+          <a:lstStyle/>
+          <a:p>
+            <a:pPr indent="0" marL="0">
+              <a:buNone/>
+            </a:pPr>
+            <a:r>
+              <a:rPr lang="en-US" sz="1300" spc="300" kern="0" dirty="0">
+                <a:solidFill>
+                  <a:srgbClr val="B8BABB"/>
+                </a:solidFill>
+                <a:latin typeface="Courier New" pitchFamily="34" charset="0"/>
+                <a:ea typeface="Courier New" pitchFamily="34" charset="-122"/>
+                <a:cs typeface="Courier New" pitchFamily="34" charset="-120"/>
+              </a:rPr>
+              <a:t>CANADA</a:t>
+            </a:r>
+            <a:endParaRPr lang="en-US" sz="1300" dirty="0"/>
+          </a:p>
+        </p:txBody>
+      </p:sp>
+      <p:sp>
+        <p:nvSpPr>
+          <p:cNvPr id="7" name="Text 4"/>
+          <p:cNvSpPr txBox="1"/>
+          <p:nvPr/>
+        </p:nvSpPr>
+        <p:spPr>
+          <a:xfrm>
             <a:off x="822960" y="2194560"/>
-            <a:ext cx="10545775" cy="2926080"/>
-          </a:xfrm>
-          <a:prstGeom prst="rect">
-            <a:avLst/>
-          </a:prstGeom>
-          <a:noFill/>
-          <a:ln/>
-        </p:spPr>
-        <p:txBody>
-          <a:bodyPr wrap="square" lIns="0" tIns="0" rIns="0" bIns="0" rtlCol="0" anchor="t"/>
-          <a:lstStyle/>
-          <a:p>
-            <a:pPr algn="ctr" indent="0" marL="0">
-              <a:lnSpc>
-                <a:spcPct val="118000"/>
-              </a:lnSpc>
-              <a:buNone/>
-            </a:pPr>
-            <a:r>
-              <a:rPr lang="en-US" sz="6600" dirty="0">
+            <a:ext cx="3291840" cy="1737360"/>
+          </a:xfrm>
+          <a:prstGeom prst="rect">
+            <a:avLst/>
+          </a:prstGeom>
+          <a:noFill/>
+          <a:ln/>
+        </p:spPr>
+        <p:txBody>
+          <a:bodyPr wrap="square" lIns="0" tIns="0" rIns="0" bIns="0" rtlCol="0" anchor="ctr"/>
+          <a:lstStyle/>
+          <a:p>
+            <a:pPr indent="0" marL="0">
+              <a:buNone/>
+            </a:pPr>
+            <a:r>
+              <a:rPr lang="en-US" sz="11000" dirty="0">
                 <a:solidFill>
                   <a:srgbClr val="F4F5F6"/>
                 </a:solidFill>
@@ -3974,231 +4310,323 @@
                 <a:ea typeface="Cambria" pitchFamily="34" charset="-122"/>
                 <a:cs typeface="Cambria" pitchFamily="34" charset="-120"/>
               </a:rPr>
-              <a:t>We built the other</a:t>
-            </a:r>
-            <a:endParaRPr lang="en-US" sz="6600" dirty="0"/>
-          </a:p>
-          <a:p>
-            <a:pPr algn="ctr" indent="0" marL="0">
-              <a:lnSpc>
-                <a:spcPct val="118000"/>
-              </a:lnSpc>
-              <a:buNone/>
-            </a:pPr>
-            <a:r>
-              <a:rPr lang="en-US" sz="6600" dirty="0">
-                <a:solidFill>
-                  <a:srgbClr val="EABA58"/>
+              <a:t>3</a:t>
+            </a:r>
+            <a:endParaRPr lang="en-US" sz="11000" dirty="0"/>
+          </a:p>
+        </p:txBody>
+      </p:sp>
+      <p:sp>
+        <p:nvSpPr>
+          <p:cNvPr id="8" name="Text 5"/>
+          <p:cNvSpPr txBox="1"/>
+          <p:nvPr/>
+        </p:nvSpPr>
+        <p:spPr>
+          <a:xfrm>
+            <a:off x="841248" y="4069080"/>
+            <a:ext cx="3383280" cy="548640"/>
+          </a:xfrm>
+          <a:prstGeom prst="rect">
+            <a:avLst/>
+          </a:prstGeom>
+          <a:noFill/>
+          <a:ln/>
+        </p:spPr>
+        <p:txBody>
+          <a:bodyPr wrap="square" lIns="0" tIns="0" rIns="0" bIns="0" rtlCol="0" anchor="ctr"/>
+          <a:lstStyle/>
+          <a:p>
+            <a:pPr indent="0" marL="0">
+              <a:buNone/>
+            </a:pPr>
+            <a:r>
+              <a:rPr lang="en-US" sz="1150" spc="200" kern="0" dirty="0">
+                <a:solidFill>
+                  <a:srgbClr val="7A7D7E"/>
+                </a:solidFill>
+                <a:latin typeface="Courier New" pitchFamily="34" charset="0"/>
+                <a:ea typeface="Courier New" pitchFamily="34" charset="-122"/>
+                <a:cs typeface="Courier New" pitchFamily="34" charset="-120"/>
+              </a:rPr>
+              <a:t>SINCE 1867 · LAST ASKED 1992</a:t>
+            </a:r>
+            <a:endParaRPr lang="en-US" sz="1150" dirty="0"/>
+          </a:p>
+        </p:txBody>
+      </p:sp>
+      <p:sp>
+        <p:nvSpPr>
+          <p:cNvPr id="9" name="Text 6"/>
+          <p:cNvSpPr txBox="1"/>
+          <p:nvPr/>
+        </p:nvSpPr>
+        <p:spPr>
+          <a:xfrm>
+            <a:off x="4434840" y="1828800"/>
+            <a:ext cx="3291840" cy="329184"/>
+          </a:xfrm>
+          <a:prstGeom prst="rect">
+            <a:avLst/>
+          </a:prstGeom>
+          <a:noFill/>
+          <a:ln/>
+        </p:spPr>
+        <p:txBody>
+          <a:bodyPr wrap="square" lIns="0" tIns="0" rIns="0" bIns="0" rtlCol="0" anchor="ctr"/>
+          <a:lstStyle/>
+          <a:p>
+            <a:pPr indent="0" marL="0">
+              <a:buNone/>
+            </a:pPr>
+            <a:r>
+              <a:rPr lang="en-US" sz="1300" spc="300" kern="0" dirty="0">
+                <a:solidFill>
+                  <a:srgbClr val="B8BABB"/>
+                </a:solidFill>
+                <a:latin typeface="Courier New" pitchFamily="34" charset="0"/>
+                <a:ea typeface="Courier New" pitchFamily="34" charset="-122"/>
+                <a:cs typeface="Courier New" pitchFamily="34" charset="-120"/>
+              </a:rPr>
+              <a:t>UNITED KINGDOM</a:t>
+            </a:r>
+            <a:endParaRPr lang="en-US" sz="1300" dirty="0"/>
+          </a:p>
+        </p:txBody>
+      </p:sp>
+      <p:sp>
+        <p:nvSpPr>
+          <p:cNvPr id="10" name="Text 7"/>
+          <p:cNvSpPr txBox="1"/>
+          <p:nvPr/>
+        </p:nvSpPr>
+        <p:spPr>
+          <a:xfrm>
+            <a:off x="4434840" y="2194560"/>
+            <a:ext cx="3291840" cy="1737360"/>
+          </a:xfrm>
+          <a:prstGeom prst="rect">
+            <a:avLst/>
+          </a:prstGeom>
+          <a:noFill/>
+          <a:ln/>
+        </p:spPr>
+        <p:txBody>
+          <a:bodyPr wrap="square" lIns="0" tIns="0" rIns="0" bIns="0" rtlCol="0" anchor="ctr"/>
+          <a:lstStyle/>
+          <a:p>
+            <a:pPr indent="0" marL="0">
+              <a:buNone/>
+            </a:pPr>
+            <a:r>
+              <a:rPr lang="en-US" sz="11000" dirty="0">
+                <a:solidFill>
+                  <a:srgbClr val="F4F5F6"/>
                 </a:solidFill>
                 <a:latin typeface="Cambria" pitchFamily="34" charset="0"/>
                 <a:ea typeface="Cambria" pitchFamily="34" charset="-122"/>
                 <a:cs typeface="Cambria" pitchFamily="34" charset="-120"/>
               </a:rPr>
-              <a:t>1,460 days.</a:t>
-            </a:r>
-            <a:endParaRPr lang="en-US" sz="6600" dirty="0"/>
-          </a:p>
-        </p:txBody>
-      </p:sp>
-      <p:sp>
-        <p:nvSpPr>
-          <p:cNvPr id="6" name="Shape 3"/>
-          <p:cNvSpPr/>
-          <p:nvPr/>
-        </p:nvSpPr>
-        <p:spPr>
-          <a:xfrm>
-            <a:off x="4678528" y="5029200"/>
-            <a:ext cx="155448" cy="155448"/>
-          </a:xfrm>
-          <a:prstGeom prst="ellipse">
-            <a:avLst/>
-          </a:prstGeom>
-          <a:solidFill>
-            <a:srgbClr val="EABA58"/>
-          </a:solidFill>
-          <a:ln/>
-        </p:spPr>
-      </p:sp>
-      <p:sp>
-        <p:nvSpPr>
-          <p:cNvPr id="7" name="Shape 4"/>
-          <p:cNvSpPr/>
-          <p:nvPr/>
-        </p:nvSpPr>
-        <p:spPr>
-          <a:xfrm>
-            <a:off x="4961992" y="5029200"/>
-            <a:ext cx="155448" cy="155448"/>
-          </a:xfrm>
-          <a:prstGeom prst="ellipse">
-            <a:avLst/>
-          </a:prstGeom>
-          <a:solidFill>
-            <a:srgbClr val="EABA58"/>
-          </a:solidFill>
-          <a:ln/>
-        </p:spPr>
-      </p:sp>
-      <p:sp>
-        <p:nvSpPr>
-          <p:cNvPr id="8" name="Shape 5"/>
-          <p:cNvSpPr/>
-          <p:nvPr/>
-        </p:nvSpPr>
-        <p:spPr>
-          <a:xfrm>
-            <a:off x="5245456" y="5029200"/>
-            <a:ext cx="155448" cy="155448"/>
-          </a:xfrm>
-          <a:prstGeom prst="ellipse">
-            <a:avLst/>
-          </a:prstGeom>
-          <a:solidFill>
-            <a:srgbClr val="EABA58"/>
-          </a:solidFill>
-          <a:ln/>
-        </p:spPr>
-      </p:sp>
-      <p:sp>
-        <p:nvSpPr>
-          <p:cNvPr id="9" name="Shape 6"/>
-          <p:cNvSpPr/>
-          <p:nvPr/>
-        </p:nvSpPr>
-        <p:spPr>
-          <a:xfrm>
-            <a:off x="5528920" y="5029200"/>
-            <a:ext cx="155448" cy="155448"/>
-          </a:xfrm>
-          <a:prstGeom prst="ellipse">
-            <a:avLst/>
-          </a:prstGeom>
-          <a:solidFill>
-            <a:srgbClr val="EABA58"/>
-          </a:solidFill>
-          <a:ln/>
-        </p:spPr>
-      </p:sp>
-      <p:sp>
-        <p:nvSpPr>
-          <p:cNvPr id="10" name="Shape 7"/>
-          <p:cNvSpPr/>
-          <p:nvPr/>
-        </p:nvSpPr>
-        <p:spPr>
-          <a:xfrm>
-            <a:off x="5812384" y="5029200"/>
-            <a:ext cx="155448" cy="155448"/>
-          </a:xfrm>
-          <a:prstGeom prst="ellipse">
-            <a:avLst/>
-          </a:prstGeom>
-          <a:solidFill>
-            <a:srgbClr val="EABA58"/>
-          </a:solidFill>
-          <a:ln/>
-        </p:spPr>
-      </p:sp>
-      <p:sp>
-        <p:nvSpPr>
-          <p:cNvPr id="11" name="Shape 8"/>
-          <p:cNvSpPr/>
-          <p:nvPr/>
-        </p:nvSpPr>
-        <p:spPr>
-          <a:xfrm>
-            <a:off x="6095848" y="5029200"/>
-            <a:ext cx="155448" cy="155448"/>
-          </a:xfrm>
-          <a:prstGeom prst="ellipse">
-            <a:avLst/>
-          </a:prstGeom>
-          <a:solidFill>
-            <a:srgbClr val="EABA58"/>
-          </a:solidFill>
-          <a:ln/>
-        </p:spPr>
-      </p:sp>
-      <p:sp>
-        <p:nvSpPr>
-          <p:cNvPr id="12" name="Shape 9"/>
-          <p:cNvSpPr/>
-          <p:nvPr/>
-        </p:nvSpPr>
-        <p:spPr>
-          <a:xfrm>
-            <a:off x="6379312" y="5029200"/>
-            <a:ext cx="155448" cy="155448"/>
-          </a:xfrm>
-          <a:prstGeom prst="ellipse">
-            <a:avLst/>
-          </a:prstGeom>
-          <a:solidFill>
-            <a:srgbClr val="EABA58"/>
-          </a:solidFill>
-          <a:ln/>
-        </p:spPr>
-      </p:sp>
-      <p:sp>
-        <p:nvSpPr>
-          <p:cNvPr id="13" name="Shape 10"/>
-          <p:cNvSpPr/>
-          <p:nvPr/>
-        </p:nvSpPr>
-        <p:spPr>
-          <a:xfrm>
-            <a:off x="6662776" y="5029200"/>
-            <a:ext cx="155448" cy="155448"/>
-          </a:xfrm>
-          <a:prstGeom prst="ellipse">
-            <a:avLst/>
-          </a:prstGeom>
-          <a:solidFill>
-            <a:srgbClr val="EABA58"/>
-          </a:solidFill>
-          <a:ln/>
-        </p:spPr>
-      </p:sp>
-      <p:sp>
-        <p:nvSpPr>
-          <p:cNvPr id="14" name="Shape 11"/>
-          <p:cNvSpPr/>
-          <p:nvPr/>
-        </p:nvSpPr>
-        <p:spPr>
-          <a:xfrm>
-            <a:off x="6946240" y="5029200"/>
-            <a:ext cx="155448" cy="155448"/>
-          </a:xfrm>
-          <a:prstGeom prst="ellipse">
-            <a:avLst/>
-          </a:prstGeom>
-          <a:solidFill>
-            <a:srgbClr val="EABA58"/>
-          </a:solidFill>
-          <a:ln/>
-        </p:spPr>
-      </p:sp>
-      <p:sp>
-        <p:nvSpPr>
-          <p:cNvPr id="15" name="Shape 12"/>
-          <p:cNvSpPr/>
-          <p:nvPr/>
-        </p:nvSpPr>
-        <p:spPr>
-          <a:xfrm>
-            <a:off x="7229704" y="5029200"/>
-            <a:ext cx="155448" cy="155448"/>
-          </a:xfrm>
-          <a:prstGeom prst="ellipse">
-            <a:avLst/>
-          </a:prstGeom>
-          <a:solidFill>
-            <a:srgbClr val="EABA58"/>
-          </a:solidFill>
-          <a:ln/>
-        </p:spPr>
+              <a:t>3</a:t>
+            </a:r>
+            <a:endParaRPr lang="en-US" sz="11000" dirty="0"/>
+          </a:p>
+        </p:txBody>
+      </p:sp>
+      <p:sp>
+        <p:nvSpPr>
+          <p:cNvPr id="11" name="Text 8"/>
+          <p:cNvSpPr txBox="1"/>
+          <p:nvPr/>
+        </p:nvSpPr>
+        <p:spPr>
+          <a:xfrm>
+            <a:off x="4453128" y="4069080"/>
+            <a:ext cx="3383280" cy="548640"/>
+          </a:xfrm>
+          <a:prstGeom prst="rect">
+            <a:avLst/>
+          </a:prstGeom>
+          <a:noFill/>
+          <a:ln/>
+        </p:spPr>
+        <p:txBody>
+          <a:bodyPr wrap="square" lIns="0" tIns="0" rIns="0" bIns="0" rtlCol="0" anchor="ctr"/>
+          <a:lstStyle/>
+          <a:p>
+            <a:pPr indent="0" marL="0">
+              <a:buNone/>
+            </a:pPr>
+            <a:r>
+              <a:rPr lang="en-US" sz="1150" spc="200" kern="0" dirty="0">
+                <a:solidFill>
+                  <a:srgbClr val="7A7D7E"/>
+                </a:solidFill>
+                <a:latin typeface="Courier New" pitchFamily="34" charset="0"/>
+                <a:ea typeface="Courier New" pitchFamily="34" charset="-122"/>
+                <a:cs typeface="Courier New" pitchFamily="34" charset="-120"/>
+              </a:rPr>
+              <a:t>IN ITS ENTIRE HISTORY</a:t>
+            </a:r>
+            <a:endParaRPr lang="en-US" sz="1150" dirty="0"/>
+          </a:p>
+        </p:txBody>
+      </p:sp>
+      <p:sp>
+        <p:nvSpPr>
+          <p:cNvPr id="12" name="Text 9"/>
+          <p:cNvSpPr txBox="1"/>
+          <p:nvPr/>
+        </p:nvSpPr>
+        <p:spPr>
+          <a:xfrm>
+            <a:off x="8046720" y="1828800"/>
+            <a:ext cx="3291840" cy="329184"/>
+          </a:xfrm>
+          <a:prstGeom prst="rect">
+            <a:avLst/>
+          </a:prstGeom>
+          <a:noFill/>
+          <a:ln/>
+        </p:spPr>
+        <p:txBody>
+          <a:bodyPr wrap="square" lIns="0" tIns="0" rIns="0" bIns="0" rtlCol="0" anchor="ctr"/>
+          <a:lstStyle/>
+          <a:p>
+            <a:pPr indent="0" marL="0">
+              <a:buNone/>
+            </a:pPr>
+            <a:r>
+              <a:rPr lang="en-US" sz="1300" spc="300" kern="0" dirty="0">
+                <a:solidFill>
+                  <a:srgbClr val="B8BABB"/>
+                </a:solidFill>
+                <a:latin typeface="Courier New" pitchFamily="34" charset="0"/>
+                <a:ea typeface="Courier New" pitchFamily="34" charset="-122"/>
+                <a:cs typeface="Courier New" pitchFamily="34" charset="-120"/>
+              </a:rPr>
+              <a:t>UNITED STATES</a:t>
+            </a:r>
+            <a:endParaRPr lang="en-US" sz="1300" dirty="0"/>
+          </a:p>
+        </p:txBody>
+      </p:sp>
+      <p:sp>
+        <p:nvSpPr>
+          <p:cNvPr id="13" name="Text 10"/>
+          <p:cNvSpPr txBox="1"/>
+          <p:nvPr/>
+        </p:nvSpPr>
+        <p:spPr>
+          <a:xfrm>
+            <a:off x="8046720" y="2194560"/>
+            <a:ext cx="3291840" cy="1737360"/>
+          </a:xfrm>
+          <a:prstGeom prst="rect">
+            <a:avLst/>
+          </a:prstGeom>
+          <a:noFill/>
+          <a:ln/>
+        </p:spPr>
+        <p:txBody>
+          <a:bodyPr wrap="square" lIns="0" tIns="0" rIns="0" bIns="0" rtlCol="0" anchor="ctr"/>
+          <a:lstStyle/>
+          <a:p>
+            <a:pPr indent="0" marL="0">
+              <a:buNone/>
+            </a:pPr>
+            <a:r>
+              <a:rPr lang="en-US" sz="11000" dirty="0">
+                <a:solidFill>
+                  <a:srgbClr val="EABA58"/>
+                </a:solidFill>
+                <a:latin typeface="Cambria" pitchFamily="34" charset="0"/>
+                <a:ea typeface="Cambria" pitchFamily="34" charset="-122"/>
+                <a:cs typeface="Cambria" pitchFamily="34" charset="-120"/>
+              </a:rPr>
+              <a:t>0</a:t>
+            </a:r>
+            <a:endParaRPr lang="en-US" sz="11000" dirty="0"/>
+          </a:p>
+        </p:txBody>
+      </p:sp>
+      <p:sp>
+        <p:nvSpPr>
+          <p:cNvPr id="14" name="Text 11"/>
+          <p:cNvSpPr txBox="1"/>
+          <p:nvPr/>
+        </p:nvSpPr>
+        <p:spPr>
+          <a:xfrm>
+            <a:off x="8065008" y="4069080"/>
+            <a:ext cx="3383280" cy="548640"/>
+          </a:xfrm>
+          <a:prstGeom prst="rect">
+            <a:avLst/>
+          </a:prstGeom>
+          <a:noFill/>
+          <a:ln/>
+        </p:spPr>
+        <p:txBody>
+          <a:bodyPr wrap="square" lIns="0" tIns="0" rIns="0" bIns="0" rtlCol="0" anchor="ctr"/>
+          <a:lstStyle/>
+          <a:p>
+            <a:pPr indent="0" marL="0">
+              <a:buNone/>
+            </a:pPr>
+            <a:r>
+              <a:rPr lang="en-US" sz="1150" spc="200" kern="0" dirty="0">
+                <a:solidFill>
+                  <a:srgbClr val="7A7D7E"/>
+                </a:solidFill>
+                <a:latin typeface="Courier New" pitchFamily="34" charset="0"/>
+                <a:ea typeface="Courier New" pitchFamily="34" charset="-122"/>
+                <a:cs typeface="Courier New" pitchFamily="34" charset="-120"/>
+              </a:rPr>
+              <a:t>NO MECHANISM EVEN EXISTS</a:t>
+            </a:r>
+            <a:endParaRPr lang="en-US" sz="1150" dirty="0"/>
+          </a:p>
+        </p:txBody>
+      </p:sp>
+      <p:sp>
+        <p:nvSpPr>
+          <p:cNvPr id="15" name="Text 12"/>
+          <p:cNvSpPr txBox="1"/>
+          <p:nvPr/>
+        </p:nvSpPr>
+        <p:spPr>
+          <a:xfrm>
+            <a:off x="822960" y="4892040"/>
+            <a:ext cx="10545775" cy="731520"/>
+          </a:xfrm>
+          <a:prstGeom prst="rect">
+            <a:avLst/>
+          </a:prstGeom>
+          <a:noFill/>
+          <a:ln/>
+        </p:spPr>
+        <p:txBody>
+          <a:bodyPr wrap="square" lIns="0" tIns="0" rIns="0" bIns="0" rtlCol="0" anchor="ctr"/>
+          <a:lstStyle/>
+          <a:p>
+            <a:pPr indent="0" marL="0">
+              <a:buNone/>
+            </a:pPr>
+            <a:r>
+              <a:rPr lang="en-US" sz="3000" dirty="0">
+                <a:solidFill>
+                  <a:srgbClr val="EABA58"/>
+                </a:solidFill>
+                <a:latin typeface="Cambria" pitchFamily="34" charset="0"/>
+                <a:ea typeface="Cambria" pitchFamily="34" charset="-122"/>
+                <a:cs typeface="Cambria" pitchFamily="34" charset="-120"/>
+              </a:rPr>
+              <a:t>If you’re under 52, Canada has never asked you anything.</a:t>
+            </a:r>
+            <a:endParaRPr lang="en-US" sz="3000" dirty="0"/>
+          </a:p>
+        </p:txBody>
       </p:sp>
     </p:spTree>
   </p:cSld>
@@ -4304,7 +4732,7 @@
                 <a:ea typeface="Courier New" pitchFamily="34" charset="-122"/>
                 <a:cs typeface="Courier New" pitchFamily="34" charset="-120"/>
               </a:rPr>
-              <a:t>07 / 10</a:t>
+              <a:t>07 / 11</a:t>
             </a:r>
             <a:endParaRPr lang="en-US" sz="1000" dirty="0"/>
           </a:p>
@@ -4318,47 +4746,8 @@
         </p:nvSpPr>
         <p:spPr>
           <a:xfrm>
-            <a:off x="822960" y="1234440"/>
-            <a:ext cx="10545775" cy="310896"/>
-          </a:xfrm>
-          <a:prstGeom prst="rect">
-            <a:avLst/>
-          </a:prstGeom>
-          <a:noFill/>
-          <a:ln/>
-        </p:spPr>
-        <p:txBody>
-          <a:bodyPr wrap="square" lIns="0" tIns="0" rIns="0" bIns="0" rtlCol="0" anchor="ctr"/>
-          <a:lstStyle/>
-          <a:p>
-            <a:pPr algn="l" indent="0" marL="0">
-              <a:buNone/>
-            </a:pPr>
-            <a:r>
-              <a:rPr lang="en-US" sz="1300" spc="500" kern="0" dirty="0">
-                <a:solidFill>
-                  <a:srgbClr val="EABA58"/>
-                </a:solidFill>
-                <a:latin typeface="Courier New" pitchFamily="34" charset="0"/>
-                <a:ea typeface="Courier New" pitchFamily="34" charset="-122"/>
-                <a:cs typeface="Courier New" pitchFamily="34" charset="-120"/>
-              </a:rPr>
-              <a:t>WHAT IT ACTUALLY IS</a:t>
-            </a:r>
-            <a:endParaRPr lang="en-US" sz="1300" dirty="0"/>
-          </a:p>
-        </p:txBody>
-      </p:sp>
-      <p:sp>
-        <p:nvSpPr>
-          <p:cNvPr id="6" name="Text 3"/>
-          <p:cNvSpPr txBox="1"/>
-          <p:nvPr/>
-        </p:nvSpPr>
-        <p:spPr>
-          <a:xfrm>
-            <a:off x="822960" y="1920240"/>
-            <a:ext cx="10545775" cy="2377440"/>
+            <a:off x="822960" y="2194560"/>
+            <a:ext cx="10545775" cy="2926080"/>
           </a:xfrm>
           <a:prstGeom prst="rect">
             <a:avLst/>
@@ -4370,14 +4759,14 @@
           <a:bodyPr wrap="square" lIns="0" tIns="0" rIns="0" bIns="0" rtlCol="0" anchor="t"/>
           <a:lstStyle/>
           <a:p>
-            <a:pPr algn="l" indent="0" marL="0">
+            <a:pPr algn="ctr" indent="0" marL="0">
               <a:lnSpc>
                 <a:spcPct val="118000"/>
               </a:lnSpc>
               <a:buNone/>
             </a:pPr>
             <a:r>
-              <a:rPr lang="en-US" sz="3800" dirty="0">
+              <a:rPr lang="en-US" sz="6600" dirty="0">
                 <a:solidFill>
                   <a:srgbClr val="F4F5F6"/>
                 </a:solidFill>
@@ -4385,16 +4774,19 @@
                 <a:ea typeface="Cambria" pitchFamily="34" charset="-122"/>
                 <a:cs typeface="Cambria" pitchFamily="34" charset="-120"/>
               </a:rPr>
-              <a:t>A mom in Calgary deciding whether her kid’s school gets built. From her kitchen table. </a:t>
-            </a:r>
-            <a:pPr algn="l" indent="0" marL="0">
+              <a:t>We built the other</a:t>
+            </a:r>
+            <a:endParaRPr lang="en-US" sz="6600" dirty="0"/>
+          </a:p>
+          <a:p>
+            <a:pPr algn="ctr" indent="0" marL="0">
               <a:lnSpc>
                 <a:spcPct val="118000"/>
               </a:lnSpc>
               <a:buNone/>
             </a:pPr>
             <a:r>
-              <a:rPr lang="en-US" sz="3800" dirty="0">
+              <a:rPr lang="en-US" sz="6600" dirty="0">
                 <a:solidFill>
                   <a:srgbClr val="EABA58"/>
                 </a:solidFill>
@@ -4402,50 +4794,211 @@
                 <a:ea typeface="Cambria" pitchFamily="34" charset="-122"/>
                 <a:cs typeface="Cambria" pitchFamily="34" charset="-120"/>
               </a:rPr>
-              <a:t>Counted once.</a:t>
-            </a:r>
-            <a:endParaRPr lang="en-US" sz="3800" dirty="0"/>
-          </a:p>
-        </p:txBody>
-      </p:sp>
-      <p:sp>
-        <p:nvSpPr>
-          <p:cNvPr id="7" name="Text 4"/>
-          <p:cNvSpPr txBox="1"/>
-          <p:nvPr/>
-        </p:nvSpPr>
-        <p:spPr>
-          <a:xfrm>
-            <a:off x="822960" y="4572000"/>
-            <a:ext cx="10545775" cy="329184"/>
-          </a:xfrm>
-          <a:prstGeom prst="rect">
-            <a:avLst/>
-          </a:prstGeom>
-          <a:noFill/>
-          <a:ln/>
-        </p:spPr>
-        <p:txBody>
-          <a:bodyPr wrap="square" lIns="0" tIns="0" rIns="0" bIns="0" rtlCol="0" anchor="ctr"/>
-          <a:lstStyle/>
-          <a:p>
-            <a:pPr indent="0" marL="0">
-              <a:buNone/>
-            </a:pPr>
-            <a:r>
-              <a:rPr lang="en-US" sz="1300" spc="300" kern="0" dirty="0">
-                <a:solidFill>
-                  <a:srgbClr val="B8BABB"/>
-                </a:solidFill>
-                <a:latin typeface="Courier New" pitchFamily="34" charset="0"/>
-                <a:ea typeface="Courier New" pitchFamily="34" charset="-122"/>
-                <a:cs typeface="Courier New" pitchFamily="34" charset="-120"/>
-              </a:rPr>
-              <a:t>ONE VERIFIED HUMAN   ·   ONE VOTE   ·   ON THE PUBLIC RECORD</a:t>
-            </a:r>
-            <a:endParaRPr lang="en-US" sz="1300" dirty="0"/>
-          </a:p>
-        </p:txBody>
+              <a:t>1,460 days.</a:t>
+            </a:r>
+            <a:endParaRPr lang="en-US" sz="6600" dirty="0"/>
+          </a:p>
+        </p:txBody>
+      </p:sp>
+      <p:sp>
+        <p:nvSpPr>
+          <p:cNvPr id="6" name="Shape 3"/>
+          <p:cNvSpPr/>
+          <p:nvPr/>
+        </p:nvSpPr>
+        <p:spPr>
+          <a:xfrm>
+            <a:off x="4678528" y="5029200"/>
+            <a:ext cx="155448" cy="155448"/>
+          </a:xfrm>
+          <a:prstGeom prst="ellipse">
+            <a:avLst/>
+          </a:prstGeom>
+          <a:solidFill>
+            <a:srgbClr val="EABA58"/>
+          </a:solidFill>
+          <a:ln/>
+        </p:spPr>
+      </p:sp>
+      <p:sp>
+        <p:nvSpPr>
+          <p:cNvPr id="7" name="Shape 4"/>
+          <p:cNvSpPr/>
+          <p:nvPr/>
+        </p:nvSpPr>
+        <p:spPr>
+          <a:xfrm>
+            <a:off x="4961992" y="5029200"/>
+            <a:ext cx="155448" cy="155448"/>
+          </a:xfrm>
+          <a:prstGeom prst="ellipse">
+            <a:avLst/>
+          </a:prstGeom>
+          <a:solidFill>
+            <a:srgbClr val="EABA58"/>
+          </a:solidFill>
+          <a:ln/>
+        </p:spPr>
+      </p:sp>
+      <p:sp>
+        <p:nvSpPr>
+          <p:cNvPr id="8" name="Shape 5"/>
+          <p:cNvSpPr/>
+          <p:nvPr/>
+        </p:nvSpPr>
+        <p:spPr>
+          <a:xfrm>
+            <a:off x="5245456" y="5029200"/>
+            <a:ext cx="155448" cy="155448"/>
+          </a:xfrm>
+          <a:prstGeom prst="ellipse">
+            <a:avLst/>
+          </a:prstGeom>
+          <a:solidFill>
+            <a:srgbClr val="EABA58"/>
+          </a:solidFill>
+          <a:ln/>
+        </p:spPr>
+      </p:sp>
+      <p:sp>
+        <p:nvSpPr>
+          <p:cNvPr id="9" name="Shape 6"/>
+          <p:cNvSpPr/>
+          <p:nvPr/>
+        </p:nvSpPr>
+        <p:spPr>
+          <a:xfrm>
+            <a:off x="5528920" y="5029200"/>
+            <a:ext cx="155448" cy="155448"/>
+          </a:xfrm>
+          <a:prstGeom prst="ellipse">
+            <a:avLst/>
+          </a:prstGeom>
+          <a:solidFill>
+            <a:srgbClr val="EABA58"/>
+          </a:solidFill>
+          <a:ln/>
+        </p:spPr>
+      </p:sp>
+      <p:sp>
+        <p:nvSpPr>
+          <p:cNvPr id="10" name="Shape 7"/>
+          <p:cNvSpPr/>
+          <p:nvPr/>
+        </p:nvSpPr>
+        <p:spPr>
+          <a:xfrm>
+            <a:off x="5812384" y="5029200"/>
+            <a:ext cx="155448" cy="155448"/>
+          </a:xfrm>
+          <a:prstGeom prst="ellipse">
+            <a:avLst/>
+          </a:prstGeom>
+          <a:solidFill>
+            <a:srgbClr val="EABA58"/>
+          </a:solidFill>
+          <a:ln/>
+        </p:spPr>
+      </p:sp>
+      <p:sp>
+        <p:nvSpPr>
+          <p:cNvPr id="11" name="Shape 8"/>
+          <p:cNvSpPr/>
+          <p:nvPr/>
+        </p:nvSpPr>
+        <p:spPr>
+          <a:xfrm>
+            <a:off x="6095848" y="5029200"/>
+            <a:ext cx="155448" cy="155448"/>
+          </a:xfrm>
+          <a:prstGeom prst="ellipse">
+            <a:avLst/>
+          </a:prstGeom>
+          <a:solidFill>
+            <a:srgbClr val="EABA58"/>
+          </a:solidFill>
+          <a:ln/>
+        </p:spPr>
+      </p:sp>
+      <p:sp>
+        <p:nvSpPr>
+          <p:cNvPr id="12" name="Shape 9"/>
+          <p:cNvSpPr/>
+          <p:nvPr/>
+        </p:nvSpPr>
+        <p:spPr>
+          <a:xfrm>
+            <a:off x="6379312" y="5029200"/>
+            <a:ext cx="155448" cy="155448"/>
+          </a:xfrm>
+          <a:prstGeom prst="ellipse">
+            <a:avLst/>
+          </a:prstGeom>
+          <a:solidFill>
+            <a:srgbClr val="EABA58"/>
+          </a:solidFill>
+          <a:ln/>
+        </p:spPr>
+      </p:sp>
+      <p:sp>
+        <p:nvSpPr>
+          <p:cNvPr id="13" name="Shape 10"/>
+          <p:cNvSpPr/>
+          <p:nvPr/>
+        </p:nvSpPr>
+        <p:spPr>
+          <a:xfrm>
+            <a:off x="6662776" y="5029200"/>
+            <a:ext cx="155448" cy="155448"/>
+          </a:xfrm>
+          <a:prstGeom prst="ellipse">
+            <a:avLst/>
+          </a:prstGeom>
+          <a:solidFill>
+            <a:srgbClr val="EABA58"/>
+          </a:solidFill>
+          <a:ln/>
+        </p:spPr>
+      </p:sp>
+      <p:sp>
+        <p:nvSpPr>
+          <p:cNvPr id="14" name="Shape 11"/>
+          <p:cNvSpPr/>
+          <p:nvPr/>
+        </p:nvSpPr>
+        <p:spPr>
+          <a:xfrm>
+            <a:off x="6946240" y="5029200"/>
+            <a:ext cx="155448" cy="155448"/>
+          </a:xfrm>
+          <a:prstGeom prst="ellipse">
+            <a:avLst/>
+          </a:prstGeom>
+          <a:solidFill>
+            <a:srgbClr val="EABA58"/>
+          </a:solidFill>
+          <a:ln/>
+        </p:spPr>
+      </p:sp>
+      <p:sp>
+        <p:nvSpPr>
+          <p:cNvPr id="15" name="Shape 12"/>
+          <p:cNvSpPr/>
+          <p:nvPr/>
+        </p:nvSpPr>
+        <p:spPr>
+          <a:xfrm>
+            <a:off x="7229704" y="5029200"/>
+            <a:ext cx="155448" cy="155448"/>
+          </a:xfrm>
+          <a:prstGeom prst="ellipse">
+            <a:avLst/>
+          </a:prstGeom>
+          <a:solidFill>
+            <a:srgbClr val="EABA58"/>
+          </a:solidFill>
+          <a:ln/>
+        </p:spPr>
       </p:sp>
     </p:spTree>
   </p:cSld>
@@ -4551,7 +5104,7 @@
                 <a:ea typeface="Courier New" pitchFamily="34" charset="-122"/>
                 <a:cs typeface="Courier New" pitchFamily="34" charset="-120"/>
               </a:rPr>
-              <a:t>08 / 10</a:t>
+              <a:t>08 / 11</a:t>
             </a:r>
             <a:endParaRPr lang="en-US" sz="1000" dirty="0"/>
           </a:p>
@@ -4590,7 +5143,7 @@
                 <a:ea typeface="Courier New" pitchFamily="34" charset="-122"/>
                 <a:cs typeface="Courier New" pitchFamily="34" charset="-120"/>
               </a:rPr>
-              <a:t>THE LAST TIME CALGARY ASKED ITS PEOPLE A QUESTION</a:t>
+              <a:t>WHAT IT ACTUALLY IS</a:t>
             </a:r>
             <a:endParaRPr lang="en-US" sz="1300" dirty="0"/>
           </a:p>
@@ -4604,24 +5157,27 @@
         </p:nvSpPr>
         <p:spPr>
           <a:xfrm>
-            <a:off x="822960" y="1965960"/>
-            <a:ext cx="3291840" cy="1097280"/>
-          </a:xfrm>
-          <a:prstGeom prst="rect">
-            <a:avLst/>
-          </a:prstGeom>
-          <a:noFill/>
-          <a:ln/>
-        </p:spPr>
-        <p:txBody>
-          <a:bodyPr wrap="square" lIns="0" tIns="0" rIns="0" bIns="0" rtlCol="0" anchor="ctr"/>
-          <a:lstStyle/>
-          <a:p>
-            <a:pPr indent="0" marL="0">
-              <a:buNone/>
-            </a:pPr>
-            <a:r>
-              <a:rPr lang="en-US" sz="5800" dirty="0">
+            <a:off x="822960" y="1920240"/>
+            <a:ext cx="10545775" cy="2377440"/>
+          </a:xfrm>
+          <a:prstGeom prst="rect">
+            <a:avLst/>
+          </a:prstGeom>
+          <a:noFill/>
+          <a:ln/>
+        </p:spPr>
+        <p:txBody>
+          <a:bodyPr wrap="square" lIns="0" tIns="0" rIns="0" bIns="0" rtlCol="0" anchor="t"/>
+          <a:lstStyle/>
+          <a:p>
+            <a:pPr algn="l" indent="0" marL="0">
+              <a:lnSpc>
+                <a:spcPct val="118000"/>
+              </a:lnSpc>
+              <a:buNone/>
+            </a:pPr>
+            <a:r>
+              <a:rPr lang="en-US" sz="3800" dirty="0">
                 <a:solidFill>
                   <a:srgbClr val="F4F5F6"/>
                 </a:solidFill>
@@ -4629,9 +5185,26 @@
                 <a:ea typeface="Cambria" pitchFamily="34" charset="-122"/>
                 <a:cs typeface="Cambria" pitchFamily="34" charset="-120"/>
               </a:rPr>
-              <a:t>$2.2M</a:t>
-            </a:r>
-            <a:endParaRPr lang="en-US" sz="5800" dirty="0"/>
+              <a:t>A mom in Calgary deciding whether her kid’s school gets built. From her kitchen table. </a:t>
+            </a:r>
+            <a:pPr algn="l" indent="0" marL="0">
+              <a:lnSpc>
+                <a:spcPct val="118000"/>
+              </a:lnSpc>
+              <a:buNone/>
+            </a:pPr>
+            <a:r>
+              <a:rPr lang="en-US" sz="3800" dirty="0">
+                <a:solidFill>
+                  <a:srgbClr val="EABA58"/>
+                </a:solidFill>
+                <a:latin typeface="Cambria" pitchFamily="34" charset="0"/>
+                <a:ea typeface="Cambria" pitchFamily="34" charset="-122"/>
+                <a:cs typeface="Cambria" pitchFamily="34" charset="-120"/>
+              </a:rPr>
+              <a:t>Counted once.</a:t>
+            </a:r>
+            <a:endParaRPr lang="en-US" sz="3800" dirty="0"/>
           </a:p>
         </p:txBody>
       </p:sp>
@@ -4643,8 +5216,8 @@
         </p:nvSpPr>
         <p:spPr>
           <a:xfrm>
-            <a:off x="841248" y="3154680"/>
-            <a:ext cx="3291840" cy="548640"/>
+            <a:off x="822960" y="4572000"/>
+            <a:ext cx="10545775" cy="329184"/>
           </a:xfrm>
           <a:prstGeom prst="rect">
             <a:avLst/>
@@ -4660,226 +5233,17 @@
               <a:buNone/>
             </a:pPr>
             <a:r>
-              <a:rPr lang="en-US" sz="1200" spc="200" kern="0" dirty="0">
-                <a:solidFill>
-                  <a:srgbClr val="7A7D7E"/>
+              <a:rPr lang="en-US" sz="1300" spc="300" kern="0" dirty="0">
+                <a:solidFill>
+                  <a:srgbClr val="B8BABB"/>
                 </a:solidFill>
                 <a:latin typeface="Courier New" pitchFamily="34" charset="0"/>
                 <a:ea typeface="Courier New" pitchFamily="34" charset="-122"/>
                 <a:cs typeface="Courier New" pitchFamily="34" charset="-120"/>
               </a:rPr>
-              <a:t>TO RUN ONE VOTE</a:t>
-            </a:r>
-            <a:endParaRPr lang="en-US" sz="1200" dirty="0"/>
-          </a:p>
-        </p:txBody>
-      </p:sp>
-      <p:sp>
-        <p:nvSpPr>
-          <p:cNvPr id="8" name="Text 5"/>
-          <p:cNvSpPr txBox="1"/>
-          <p:nvPr/>
-        </p:nvSpPr>
-        <p:spPr>
-          <a:xfrm>
-            <a:off x="4434840" y="1965960"/>
-            <a:ext cx="3291840" cy="1097280"/>
-          </a:xfrm>
-          <a:prstGeom prst="rect">
-            <a:avLst/>
-          </a:prstGeom>
-          <a:noFill/>
-          <a:ln/>
-        </p:spPr>
-        <p:txBody>
-          <a:bodyPr wrap="square" lIns="0" tIns="0" rIns="0" bIns="0" rtlCol="0" anchor="ctr"/>
-          <a:lstStyle/>
-          <a:p>
-            <a:pPr indent="0" marL="0">
-              <a:buNone/>
-            </a:pPr>
-            <a:r>
-              <a:rPr lang="en-US" sz="5800" dirty="0">
-                <a:solidFill>
-                  <a:srgbClr val="F4F5F6"/>
-                </a:solidFill>
-                <a:latin typeface="Cambria" pitchFamily="34" charset="0"/>
-                <a:ea typeface="Cambria" pitchFamily="34" charset="-122"/>
-                <a:cs typeface="Cambria" pitchFamily="34" charset="-120"/>
-              </a:rPr>
-              <a:t>3 YEARS</a:t>
-            </a:r>
-            <a:endParaRPr lang="en-US" sz="5800" dirty="0"/>
-          </a:p>
-        </p:txBody>
-      </p:sp>
-      <p:sp>
-        <p:nvSpPr>
-          <p:cNvPr id="9" name="Text 6"/>
-          <p:cNvSpPr txBox="1"/>
-          <p:nvPr/>
-        </p:nvSpPr>
-        <p:spPr>
-          <a:xfrm>
-            <a:off x="4453128" y="3154680"/>
-            <a:ext cx="3291840" cy="548640"/>
-          </a:xfrm>
-          <a:prstGeom prst="rect">
-            <a:avLst/>
-          </a:prstGeom>
-          <a:noFill/>
-          <a:ln/>
-        </p:spPr>
-        <p:txBody>
-          <a:bodyPr wrap="square" lIns="0" tIns="0" rIns="0" bIns="0" rtlCol="0" anchor="ctr"/>
-          <a:lstStyle/>
-          <a:p>
-            <a:pPr indent="0" marL="0">
-              <a:buNone/>
-            </a:pPr>
-            <a:r>
-              <a:rPr lang="en-US" sz="1200" spc="200" kern="0" dirty="0">
-                <a:solidFill>
-                  <a:srgbClr val="7A7D7E"/>
-                </a:solidFill>
-                <a:latin typeface="Courier New" pitchFamily="34" charset="0"/>
-                <a:ea typeface="Courier New" pitchFamily="34" charset="-122"/>
-                <a:cs typeface="Courier New" pitchFamily="34" charset="-120"/>
-              </a:rPr>
-              <a:t>COMMITTEE TO ANSWER</a:t>
-            </a:r>
-            <a:endParaRPr lang="en-US" sz="1200" dirty="0"/>
-          </a:p>
-        </p:txBody>
-      </p:sp>
-      <p:sp>
-        <p:nvSpPr>
-          <p:cNvPr id="10" name="Text 7"/>
-          <p:cNvSpPr txBox="1"/>
-          <p:nvPr/>
-        </p:nvSpPr>
-        <p:spPr>
-          <a:xfrm>
-            <a:off x="8046720" y="1965960"/>
-            <a:ext cx="3291840" cy="1097280"/>
-          </a:xfrm>
-          <a:prstGeom prst="rect">
-            <a:avLst/>
-          </a:prstGeom>
-          <a:noFill/>
-          <a:ln/>
-        </p:spPr>
-        <p:txBody>
-          <a:bodyPr wrap="square" lIns="0" tIns="0" rIns="0" bIns="0" rtlCol="0" anchor="ctr"/>
-          <a:lstStyle/>
-          <a:p>
-            <a:pPr indent="0" marL="0">
-              <a:buNone/>
-            </a:pPr>
-            <a:r>
-              <a:rPr lang="en-US" sz="5800" dirty="0">
-                <a:solidFill>
-                  <a:srgbClr val="F4F5F6"/>
-                </a:solidFill>
-                <a:latin typeface="Cambria" pitchFamily="34" charset="0"/>
-                <a:ea typeface="Cambria" pitchFamily="34" charset="-122"/>
-                <a:cs typeface="Cambria" pitchFamily="34" charset="-120"/>
-              </a:rPr>
-              <a:t>1 DAY</a:t>
-            </a:r>
-            <a:endParaRPr lang="en-US" sz="5800" dirty="0"/>
-          </a:p>
-        </p:txBody>
-      </p:sp>
-      <p:sp>
-        <p:nvSpPr>
-          <p:cNvPr id="11" name="Text 8"/>
-          <p:cNvSpPr txBox="1"/>
-          <p:nvPr/>
-        </p:nvSpPr>
-        <p:spPr>
-          <a:xfrm>
-            <a:off x="8065008" y="3154680"/>
-            <a:ext cx="3291840" cy="548640"/>
-          </a:xfrm>
-          <a:prstGeom prst="rect">
-            <a:avLst/>
-          </a:prstGeom>
-          <a:noFill/>
-          <a:ln/>
-        </p:spPr>
-        <p:txBody>
-          <a:bodyPr wrap="square" lIns="0" tIns="0" rIns="0" bIns="0" rtlCol="0" anchor="ctr"/>
-          <a:lstStyle/>
-          <a:p>
-            <a:pPr indent="0" marL="0">
-              <a:buNone/>
-            </a:pPr>
-            <a:r>
-              <a:rPr lang="en-US" sz="1200" spc="200" kern="0" dirty="0">
-                <a:solidFill>
-                  <a:srgbClr val="7A7D7E"/>
-                </a:solidFill>
-                <a:latin typeface="Courier New" pitchFamily="34" charset="0"/>
-                <a:ea typeface="Courier New" pitchFamily="34" charset="-122"/>
-                <a:cs typeface="Courier New" pitchFamily="34" charset="-120"/>
-              </a:rPr>
-              <a:t>THEN IT WAS TAKEN APART</a:t>
-            </a:r>
-            <a:endParaRPr lang="en-US" sz="1200" dirty="0"/>
-          </a:p>
-        </p:txBody>
-      </p:sp>
-      <p:sp>
-        <p:nvSpPr>
-          <p:cNvPr id="12" name="Text 9"/>
-          <p:cNvSpPr txBox="1"/>
-          <p:nvPr/>
-        </p:nvSpPr>
-        <p:spPr>
-          <a:xfrm>
-            <a:off x="822960" y="4297680"/>
-            <a:ext cx="10545775" cy="822960"/>
-          </a:xfrm>
-          <a:prstGeom prst="rect">
-            <a:avLst/>
-          </a:prstGeom>
-          <a:noFill/>
-          <a:ln/>
-        </p:spPr>
-        <p:txBody>
-          <a:bodyPr wrap="square" lIns="0" tIns="0" rIns="0" bIns="0" rtlCol="0" anchor="ctr"/>
-          <a:lstStyle/>
-          <a:p>
-            <a:pPr indent="0" marL="0">
-              <a:buNone/>
-            </a:pPr>
-            <a:r>
-              <a:rPr lang="en-US" sz="3200" dirty="0">
-                <a:solidFill>
-                  <a:srgbClr val="B8BABB"/>
-                </a:solidFill>
-                <a:latin typeface="Cambria" pitchFamily="34" charset="0"/>
-                <a:ea typeface="Cambria" pitchFamily="34" charset="-122"/>
-                <a:cs typeface="Cambria" pitchFamily="34" charset="-120"/>
-              </a:rPr>
-              <a:t>On Represent: </a:t>
-            </a:r>
-            <a:pPr indent="0" marL="0">
-              <a:buNone/>
-            </a:pPr>
-            <a:r>
-              <a:rPr lang="en-US" sz="3200" dirty="0">
-                <a:solidFill>
-                  <a:srgbClr val="EABA58"/>
-                </a:solidFill>
-                <a:latin typeface="Cambria" pitchFamily="34" charset="0"/>
-                <a:ea typeface="Cambria" pitchFamily="34" charset="-122"/>
-                <a:cs typeface="Cambria" pitchFamily="34" charset="-120"/>
-              </a:rPr>
-              <a:t>free, and answered by Friday.</a:t>
-            </a:r>
-            <a:endParaRPr lang="en-US" sz="3200" dirty="0"/>
+              <a:t>ONE VERIFIED HUMAN   ·   ONE VOTE   ·   ON THE PUBLIC RECORD</a:t>
+            </a:r>
+            <a:endParaRPr lang="en-US" sz="1300" dirty="0"/>
           </a:p>
         </p:txBody>
       </p:sp>
@@ -4987,7 +5351,7 @@
                 <a:ea typeface="Courier New" pitchFamily="34" charset="-122"/>
                 <a:cs typeface="Courier New" pitchFamily="34" charset="-120"/>
               </a:rPr>
-              <a:t>09 / 10</a:t>
+              <a:t>09 / 11</a:t>
             </a:r>
             <a:endParaRPr lang="en-US" sz="1000" dirty="0"/>
           </a:p>
@@ -5001,57 +5365,321 @@
         </p:nvSpPr>
         <p:spPr>
           <a:xfrm>
-            <a:off x="822960" y="2103120"/>
-            <a:ext cx="10545775" cy="2926080"/>
-          </a:xfrm>
-          <a:prstGeom prst="rect">
-            <a:avLst/>
-          </a:prstGeom>
-          <a:noFill/>
-          <a:ln/>
-        </p:spPr>
-        <p:txBody>
-          <a:bodyPr wrap="square" lIns="0" tIns="0" rIns="0" bIns="0" rtlCol="0" anchor="t"/>
-          <a:lstStyle/>
-          <a:p>
-            <a:pPr algn="ctr" indent="0" marL="0">
-              <a:lnSpc>
-                <a:spcPct val="118000"/>
-              </a:lnSpc>
-              <a:buNone/>
-            </a:pPr>
-            <a:r>
-              <a:rPr lang="en-US" sz="8000" dirty="0">
+            <a:off x="822960" y="1234440"/>
+            <a:ext cx="10545775" cy="310896"/>
+          </a:xfrm>
+          <a:prstGeom prst="rect">
+            <a:avLst/>
+          </a:prstGeom>
+          <a:noFill/>
+          <a:ln/>
+        </p:spPr>
+        <p:txBody>
+          <a:bodyPr wrap="square" lIns="0" tIns="0" rIns="0" bIns="0" rtlCol="0" anchor="ctr"/>
+          <a:lstStyle/>
+          <a:p>
+            <a:pPr algn="l" indent="0" marL="0">
+              <a:buNone/>
+            </a:pPr>
+            <a:r>
+              <a:rPr lang="en-US" sz="1300" spc="500" kern="0" dirty="0">
                 <a:solidFill>
                   <a:srgbClr val="EABA58"/>
+                </a:solidFill>
+                <a:latin typeface="Courier New" pitchFamily="34" charset="0"/>
+                <a:ea typeface="Courier New" pitchFamily="34" charset="-122"/>
+                <a:cs typeface="Courier New" pitchFamily="34" charset="-120"/>
+              </a:rPr>
+              <a:t>THE LAST TIME CALGARY ASKED ITS PEOPLE A QUESTION</a:t>
+            </a:r>
+            <a:endParaRPr lang="en-US" sz="1300" dirty="0"/>
+          </a:p>
+        </p:txBody>
+      </p:sp>
+      <p:sp>
+        <p:nvSpPr>
+          <p:cNvPr id="6" name="Text 3"/>
+          <p:cNvSpPr txBox="1"/>
+          <p:nvPr/>
+        </p:nvSpPr>
+        <p:spPr>
+          <a:xfrm>
+            <a:off x="822960" y="1965960"/>
+            <a:ext cx="3291840" cy="1097280"/>
+          </a:xfrm>
+          <a:prstGeom prst="rect">
+            <a:avLst/>
+          </a:prstGeom>
+          <a:noFill/>
+          <a:ln/>
+        </p:spPr>
+        <p:txBody>
+          <a:bodyPr wrap="square" lIns="0" tIns="0" rIns="0" bIns="0" rtlCol="0" anchor="ctr"/>
+          <a:lstStyle/>
+          <a:p>
+            <a:pPr indent="0" marL="0">
+              <a:buNone/>
+            </a:pPr>
+            <a:r>
+              <a:rPr lang="en-US" sz="5800" dirty="0">
+                <a:solidFill>
+                  <a:srgbClr val="F4F5F6"/>
                 </a:solidFill>
                 <a:latin typeface="Cambria" pitchFamily="34" charset="0"/>
                 <a:ea typeface="Cambria" pitchFamily="34" charset="-122"/>
                 <a:cs typeface="Cambria" pitchFamily="34" charset="-120"/>
               </a:rPr>
-              <a:t>The majority</a:t>
-            </a:r>
-            <a:endParaRPr lang="en-US" sz="8000" dirty="0"/>
-          </a:p>
-          <a:p>
-            <a:pPr algn="ctr" indent="0" marL="0">
-              <a:lnSpc>
-                <a:spcPct val="118000"/>
-              </a:lnSpc>
-              <a:buNone/>
-            </a:pPr>
-            <a:r>
-              <a:rPr lang="en-US" sz="8000" dirty="0">
-                <a:solidFill>
-                  <a:srgbClr val="EABA58"/>
+              <a:t>$2.2M</a:t>
+            </a:r>
+            <a:endParaRPr lang="en-US" sz="5800" dirty="0"/>
+          </a:p>
+        </p:txBody>
+      </p:sp>
+      <p:sp>
+        <p:nvSpPr>
+          <p:cNvPr id="7" name="Text 4"/>
+          <p:cNvSpPr txBox="1"/>
+          <p:nvPr/>
+        </p:nvSpPr>
+        <p:spPr>
+          <a:xfrm>
+            <a:off x="841248" y="3154680"/>
+            <a:ext cx="3291840" cy="548640"/>
+          </a:xfrm>
+          <a:prstGeom prst="rect">
+            <a:avLst/>
+          </a:prstGeom>
+          <a:noFill/>
+          <a:ln/>
+        </p:spPr>
+        <p:txBody>
+          <a:bodyPr wrap="square" lIns="0" tIns="0" rIns="0" bIns="0" rtlCol="0" anchor="ctr"/>
+          <a:lstStyle/>
+          <a:p>
+            <a:pPr indent="0" marL="0">
+              <a:buNone/>
+            </a:pPr>
+            <a:r>
+              <a:rPr lang="en-US" sz="1200" spc="200" kern="0" dirty="0">
+                <a:solidFill>
+                  <a:srgbClr val="7A7D7E"/>
+                </a:solidFill>
+                <a:latin typeface="Courier New" pitchFamily="34" charset="0"/>
+                <a:ea typeface="Courier New" pitchFamily="34" charset="-122"/>
+                <a:cs typeface="Courier New" pitchFamily="34" charset="-120"/>
+              </a:rPr>
+              <a:t>TO RUN ONE VOTE</a:t>
+            </a:r>
+            <a:endParaRPr lang="en-US" sz="1200" dirty="0"/>
+          </a:p>
+        </p:txBody>
+      </p:sp>
+      <p:sp>
+        <p:nvSpPr>
+          <p:cNvPr id="8" name="Text 5"/>
+          <p:cNvSpPr txBox="1"/>
+          <p:nvPr/>
+        </p:nvSpPr>
+        <p:spPr>
+          <a:xfrm>
+            <a:off x="4434840" y="1965960"/>
+            <a:ext cx="3291840" cy="1097280"/>
+          </a:xfrm>
+          <a:prstGeom prst="rect">
+            <a:avLst/>
+          </a:prstGeom>
+          <a:noFill/>
+          <a:ln/>
+        </p:spPr>
+        <p:txBody>
+          <a:bodyPr wrap="square" lIns="0" tIns="0" rIns="0" bIns="0" rtlCol="0" anchor="ctr"/>
+          <a:lstStyle/>
+          <a:p>
+            <a:pPr indent="0" marL="0">
+              <a:buNone/>
+            </a:pPr>
+            <a:r>
+              <a:rPr lang="en-US" sz="5800" dirty="0">
+                <a:solidFill>
+                  <a:srgbClr val="F4F5F6"/>
                 </a:solidFill>
                 <a:latin typeface="Cambria" pitchFamily="34" charset="0"/>
                 <a:ea typeface="Cambria" pitchFamily="34" charset="-122"/>
                 <a:cs typeface="Cambria" pitchFamily="34" charset="-120"/>
               </a:rPr>
-              <a:t>chooses good.</a:t>
-            </a:r>
-            <a:endParaRPr lang="en-US" sz="8000" dirty="0"/>
+              <a:t>3 YEARS</a:t>
+            </a:r>
+            <a:endParaRPr lang="en-US" sz="5800" dirty="0"/>
+          </a:p>
+        </p:txBody>
+      </p:sp>
+      <p:sp>
+        <p:nvSpPr>
+          <p:cNvPr id="9" name="Text 6"/>
+          <p:cNvSpPr txBox="1"/>
+          <p:nvPr/>
+        </p:nvSpPr>
+        <p:spPr>
+          <a:xfrm>
+            <a:off x="4453128" y="3154680"/>
+            <a:ext cx="3291840" cy="548640"/>
+          </a:xfrm>
+          <a:prstGeom prst="rect">
+            <a:avLst/>
+          </a:prstGeom>
+          <a:noFill/>
+          <a:ln/>
+        </p:spPr>
+        <p:txBody>
+          <a:bodyPr wrap="square" lIns="0" tIns="0" rIns="0" bIns="0" rtlCol="0" anchor="ctr"/>
+          <a:lstStyle/>
+          <a:p>
+            <a:pPr indent="0" marL="0">
+              <a:buNone/>
+            </a:pPr>
+            <a:r>
+              <a:rPr lang="en-US" sz="1200" spc="200" kern="0" dirty="0">
+                <a:solidFill>
+                  <a:srgbClr val="7A7D7E"/>
+                </a:solidFill>
+                <a:latin typeface="Courier New" pitchFamily="34" charset="0"/>
+                <a:ea typeface="Courier New" pitchFamily="34" charset="-122"/>
+                <a:cs typeface="Courier New" pitchFamily="34" charset="-120"/>
+              </a:rPr>
+              <a:t>COMMITTEE TO ANSWER</a:t>
+            </a:r>
+            <a:endParaRPr lang="en-US" sz="1200" dirty="0"/>
+          </a:p>
+        </p:txBody>
+      </p:sp>
+      <p:sp>
+        <p:nvSpPr>
+          <p:cNvPr id="10" name="Text 7"/>
+          <p:cNvSpPr txBox="1"/>
+          <p:nvPr/>
+        </p:nvSpPr>
+        <p:spPr>
+          <a:xfrm>
+            <a:off x="8046720" y="1965960"/>
+            <a:ext cx="3291840" cy="1097280"/>
+          </a:xfrm>
+          <a:prstGeom prst="rect">
+            <a:avLst/>
+          </a:prstGeom>
+          <a:noFill/>
+          <a:ln/>
+        </p:spPr>
+        <p:txBody>
+          <a:bodyPr wrap="square" lIns="0" tIns="0" rIns="0" bIns="0" rtlCol="0" anchor="ctr"/>
+          <a:lstStyle/>
+          <a:p>
+            <a:pPr indent="0" marL="0">
+              <a:buNone/>
+            </a:pPr>
+            <a:r>
+              <a:rPr lang="en-US" sz="5800" dirty="0">
+                <a:solidFill>
+                  <a:srgbClr val="F4F5F6"/>
+                </a:solidFill>
+                <a:latin typeface="Cambria" pitchFamily="34" charset="0"/>
+                <a:ea typeface="Cambria" pitchFamily="34" charset="-122"/>
+                <a:cs typeface="Cambria" pitchFamily="34" charset="-120"/>
+              </a:rPr>
+              <a:t>1 DAY</a:t>
+            </a:r>
+            <a:endParaRPr lang="en-US" sz="5800" dirty="0"/>
+          </a:p>
+        </p:txBody>
+      </p:sp>
+      <p:sp>
+        <p:nvSpPr>
+          <p:cNvPr id="11" name="Text 8"/>
+          <p:cNvSpPr txBox="1"/>
+          <p:nvPr/>
+        </p:nvSpPr>
+        <p:spPr>
+          <a:xfrm>
+            <a:off x="8065008" y="3154680"/>
+            <a:ext cx="3291840" cy="548640"/>
+          </a:xfrm>
+          <a:prstGeom prst="rect">
+            <a:avLst/>
+          </a:prstGeom>
+          <a:noFill/>
+          <a:ln/>
+        </p:spPr>
+        <p:txBody>
+          <a:bodyPr wrap="square" lIns="0" tIns="0" rIns="0" bIns="0" rtlCol="0" anchor="ctr"/>
+          <a:lstStyle/>
+          <a:p>
+            <a:pPr indent="0" marL="0">
+              <a:buNone/>
+            </a:pPr>
+            <a:r>
+              <a:rPr lang="en-US" sz="1200" spc="200" kern="0" dirty="0">
+                <a:solidFill>
+                  <a:srgbClr val="7A7D7E"/>
+                </a:solidFill>
+                <a:latin typeface="Courier New" pitchFamily="34" charset="0"/>
+                <a:ea typeface="Courier New" pitchFamily="34" charset="-122"/>
+                <a:cs typeface="Courier New" pitchFamily="34" charset="-120"/>
+              </a:rPr>
+              <a:t>THEN IT WAS TAKEN APART</a:t>
+            </a:r>
+            <a:endParaRPr lang="en-US" sz="1200" dirty="0"/>
+          </a:p>
+        </p:txBody>
+      </p:sp>
+      <p:sp>
+        <p:nvSpPr>
+          <p:cNvPr id="12" name="Text 9"/>
+          <p:cNvSpPr txBox="1"/>
+          <p:nvPr/>
+        </p:nvSpPr>
+        <p:spPr>
+          <a:xfrm>
+            <a:off x="822960" y="4297680"/>
+            <a:ext cx="10545775" cy="822960"/>
+          </a:xfrm>
+          <a:prstGeom prst="rect">
+            <a:avLst/>
+          </a:prstGeom>
+          <a:noFill/>
+          <a:ln/>
+        </p:spPr>
+        <p:txBody>
+          <a:bodyPr wrap="square" lIns="0" tIns="0" rIns="0" bIns="0" rtlCol="0" anchor="ctr"/>
+          <a:lstStyle/>
+          <a:p>
+            <a:pPr indent="0" marL="0">
+              <a:buNone/>
+            </a:pPr>
+            <a:r>
+              <a:rPr lang="en-US" sz="3200" dirty="0">
+                <a:solidFill>
+                  <a:srgbClr val="B8BABB"/>
+                </a:solidFill>
+                <a:latin typeface="Cambria" pitchFamily="34" charset="0"/>
+                <a:ea typeface="Cambria" pitchFamily="34" charset="-122"/>
+                <a:cs typeface="Cambria" pitchFamily="34" charset="-120"/>
+              </a:rPr>
+              <a:t>On Represent: </a:t>
+            </a:r>
+            <a:pPr indent="0" marL="0">
+              <a:buNone/>
+            </a:pPr>
+            <a:r>
+              <a:rPr lang="en-US" sz="3200" dirty="0">
+                <a:solidFill>
+                  <a:srgbClr val="EABA58"/>
+                </a:solidFill>
+                <a:latin typeface="Cambria" pitchFamily="34" charset="0"/>
+                <a:ea typeface="Cambria" pitchFamily="34" charset="-122"/>
+                <a:cs typeface="Cambria" pitchFamily="34" charset="-120"/>
+              </a:rPr>
+              <a:t>free, and answered by Friday.</a:t>
+            </a:r>
+            <a:endParaRPr lang="en-US" sz="3200" dirty="0"/>
           </a:p>
         </p:txBody>
       </p:sp>

</xml_diff>